<commit_message>
Add chronological evaluation and update presentation
</commit_message>
<xml_diff>
--- a/Temporal Feature-Driven Machine Learning Framework for ODI Score Prediction and Player Role Classification.pptx
+++ b/Temporal Feature-Driven Machine Learning Framework for ODI Score Prediction and Player Role Classification.pptx
@@ -280,7 +280,7 @@
       </p15:sldGuideLst>
     </p:ext>
     <p:ext uri="GoogleSlidesCustomDataVersion2">
-      <go:slidesCustomData xmlns:go="http://customooxmlschemas.google.com/" r:id="rId31" roundtripDataSignature="AMtx7mjJH1LDtARSwcevSJ9T+hndjfQgVg=="/>
+      <go:slidesCustomData xmlns:go="http://customooxmlschemas.google.com/" r:id="rId31" roundtripDataSignature="AMtx7mgBtTrHhpQcDgTjyrGo34QApjJaHw=="/>
     </p:ext>
   </p:extLst>
 </p:presentation>
@@ -4783,7 +4783,7 @@
               <a:srgbClr val="000097"/>
             </a:solidFill>
             <a:prstDash val="solid"/>
-            <a:miter lim="80"/>
+            <a:miter lim="0"/>
             <a:headEnd len="sm" w="sm" type="none"/>
             <a:tailEnd len="sm" w="sm" type="none"/>
           </a:ln>
@@ -5376,7 +5376,7 @@
               <a:schemeClr val="dk1"/>
             </a:solidFill>
             <a:prstDash val="solid"/>
-            <a:miter lim="80"/>
+            <a:miter lim="0"/>
             <a:headEnd len="sm" w="sm" type="none"/>
             <a:tailEnd len="sm" w="sm" type="none"/>
           </a:ln>
@@ -7111,7 +7111,7 @@
               <a:srgbClr val="000097"/>
             </a:solidFill>
             <a:prstDash val="solid"/>
-            <a:miter lim="80"/>
+            <a:miter lim="0"/>
             <a:headEnd len="sm" w="sm" type="none"/>
             <a:tailEnd len="sm" w="sm" type="none"/>
           </a:ln>
@@ -7872,7 +7872,28 @@
                 <a:cs typeface="Times New Roman"/>
                 <a:sym typeface="Times New Roman"/>
               </a:rPr>
-              <a:t>• Use a chronological match-level split so test matches do not overlap with training matches.</a:t>
+              <a:t>• Use a </a:t>
+            </a:r>
+            <a:r>
+              <a:rPr lang="en-US" sz="1600">
+                <a:latin typeface="Times New Roman"/>
+                <a:ea typeface="Times New Roman"/>
+                <a:cs typeface="Times New Roman"/>
+                <a:sym typeface="Times New Roman"/>
+              </a:rPr>
+              <a:t>randomized match-level split so test matches do not overlap </a:t>
+            </a:r>
+            <a:r>
+              <a:rPr b="0" i="0" lang="en-US" sz="1600" u="none" cap="none" strike="noStrike">
+                <a:solidFill>
+                  <a:srgbClr val="000000"/>
+                </a:solidFill>
+                <a:latin typeface="Times New Roman"/>
+                <a:ea typeface="Times New Roman"/>
+                <a:cs typeface="Times New Roman"/>
+                <a:sym typeface="Times New Roman"/>
+              </a:rPr>
+              <a:t>with training matches.</a:t>
             </a:r>
             <a:endParaRPr b="0" i="0" sz="1400" u="none" cap="none" strike="noStrike">
               <a:solidFill>
@@ -8686,8 +8707,8 @@
         </p:nvSpPr>
         <p:spPr>
           <a:xfrm>
-            <a:off x="282498" y="854927"/>
-            <a:ext cx="8576494" cy="3670314"/>
+            <a:off x="77675" y="736600"/>
+            <a:ext cx="8956800" cy="3884700"/>
           </a:xfrm>
           <a:prstGeom prst="rect">
             <a:avLst/>
@@ -8703,7 +8724,7 @@
           </a:bodyPr>
           <a:lstStyle/>
           <a:p>
-            <a:pPr indent="0" lvl="0" marL="0" marR="0" rtl="0" algn="l">
+            <a:pPr indent="-317500" lvl="0" marL="457200" marR="0" rtl="0" algn="l">
               <a:lnSpc>
                 <a:spcPct val="100000"/>
               </a:lnSpc>
@@ -8717,20 +8738,597 @@
                 <a:srgbClr val="000000"/>
               </a:buClr>
               <a:buSzPts val="1400"/>
-              <a:buFont typeface="Arial"/>
-              <a:buNone/>
-            </a:pPr>
-            <a:r>
-              <a:rPr b="0" i="0" lang="en-US" sz="1400" u="none" cap="none" strike="noStrike">
-                <a:solidFill>
-                  <a:srgbClr val="000000"/>
-                </a:solidFill>
+              <a:buFont typeface="Times New Roman"/>
+              <a:buChar char="●"/>
+            </a:pPr>
+            <a:r>
+              <a:rPr lang="en-US">
                 <a:latin typeface="Times New Roman"/>
                 <a:ea typeface="Times New Roman"/>
                 <a:cs typeface="Times New Roman"/>
                 <a:sym typeface="Times New Roman"/>
               </a:rPr>
-              <a:t>• 13 numerical features include innings state, run rate, overs remaining and temporal statistics.</a:t>
+              <a:t>13</a:t>
+            </a:r>
+            <a:r>
+              <a:rPr b="0" i="0" lang="en-US" sz="1400" u="none" cap="none" strike="noStrike">
+                <a:solidFill>
+                  <a:srgbClr val="000000"/>
+                </a:solidFill>
+                <a:latin typeface="Times New Roman"/>
+                <a:ea typeface="Times New Roman"/>
+                <a:cs typeface="Times New Roman"/>
+                <a:sym typeface="Times New Roman"/>
+              </a:rPr>
+              <a:t> numerical features include </a:t>
+            </a:r>
+            <a:endParaRPr>
+              <a:latin typeface="Times New Roman"/>
+              <a:ea typeface="Times New Roman"/>
+              <a:cs typeface="Times New Roman"/>
+              <a:sym typeface="Times New Roman"/>
+            </a:endParaRPr>
+          </a:p>
+          <a:p>
+            <a:pPr indent="-304800" lvl="1" marL="914400" marR="0" rtl="0" algn="l">
+              <a:lnSpc>
+                <a:spcPct val="100000"/>
+              </a:lnSpc>
+              <a:spcBef>
+                <a:spcPts val="0"/>
+              </a:spcBef>
+              <a:spcAft>
+                <a:spcPts val="0"/>
+              </a:spcAft>
+              <a:buClr>
+                <a:srgbClr val="000000"/>
+              </a:buClr>
+              <a:buSzPts val="1200"/>
+              <a:buFont typeface="Times New Roman"/>
+              <a:buChar char="○"/>
+            </a:pPr>
+            <a:r>
+              <a:rPr b="0" i="0" lang="en-US" sz="1200" u="none" cap="none" strike="noStrike">
+                <a:solidFill>
+                  <a:srgbClr val="000000"/>
+                </a:solidFill>
+                <a:latin typeface="Times New Roman"/>
+                <a:ea typeface="Times New Roman"/>
+                <a:cs typeface="Times New Roman"/>
+                <a:sym typeface="Times New Roman"/>
+              </a:rPr>
+              <a:t>innings</a:t>
+            </a:r>
+            <a:endParaRPr sz="1200">
+              <a:latin typeface="Times New Roman"/>
+              <a:ea typeface="Times New Roman"/>
+              <a:cs typeface="Times New Roman"/>
+              <a:sym typeface="Times New Roman"/>
+            </a:endParaRPr>
+          </a:p>
+          <a:p>
+            <a:pPr indent="-304800" lvl="1" marL="914400" marR="0" rtl="0" algn="l">
+              <a:lnSpc>
+                <a:spcPct val="100000"/>
+              </a:lnSpc>
+              <a:spcBef>
+                <a:spcPts val="0"/>
+              </a:spcBef>
+              <a:spcAft>
+                <a:spcPts val="0"/>
+              </a:spcAft>
+              <a:buSzPts val="1200"/>
+              <a:buFont typeface="Times New Roman"/>
+              <a:buChar char="○"/>
+            </a:pPr>
+            <a:r>
+              <a:rPr lang="en-US" sz="1200">
+                <a:latin typeface="Times New Roman"/>
+                <a:ea typeface="Times New Roman"/>
+                <a:cs typeface="Times New Roman"/>
+                <a:sym typeface="Times New Roman"/>
+              </a:rPr>
+              <a:t>over</a:t>
+            </a:r>
+            <a:r>
+              <a:rPr b="0" i="0" lang="en-US" sz="1200" u="none" cap="none" strike="noStrike">
+                <a:solidFill>
+                  <a:srgbClr val="000000"/>
+                </a:solidFill>
+                <a:latin typeface="Times New Roman"/>
+                <a:ea typeface="Times New Roman"/>
+                <a:cs typeface="Times New Roman"/>
+                <a:sym typeface="Times New Roman"/>
+              </a:rPr>
+              <a:t> </a:t>
+            </a:r>
+            <a:endParaRPr b="0" i="0" sz="1200" u="none" cap="none" strike="noStrike">
+              <a:solidFill>
+                <a:srgbClr val="000000"/>
+              </a:solidFill>
+              <a:latin typeface="Times New Roman"/>
+              <a:ea typeface="Times New Roman"/>
+              <a:cs typeface="Times New Roman"/>
+              <a:sym typeface="Times New Roman"/>
+            </a:endParaRPr>
+          </a:p>
+          <a:p>
+            <a:pPr indent="-304800" lvl="1" marL="914400" marR="0" rtl="0" algn="l">
+              <a:lnSpc>
+                <a:spcPct val="100000"/>
+              </a:lnSpc>
+              <a:spcBef>
+                <a:spcPts val="0"/>
+              </a:spcBef>
+              <a:spcAft>
+                <a:spcPts val="0"/>
+              </a:spcAft>
+              <a:buClr>
+                <a:srgbClr val="000000"/>
+              </a:buClr>
+              <a:buSzPts val="1200"/>
+              <a:buFont typeface="Times New Roman"/>
+              <a:buChar char="○"/>
+            </a:pPr>
+            <a:r>
+              <a:rPr b="0" i="0" lang="en-US" sz="1200" u="none" cap="none" strike="noStrike">
+                <a:solidFill>
+                  <a:srgbClr val="000000"/>
+                </a:solidFill>
+                <a:latin typeface="Times New Roman"/>
+                <a:ea typeface="Times New Roman"/>
+                <a:cs typeface="Times New Roman"/>
+                <a:sym typeface="Times New Roman"/>
+              </a:rPr>
+              <a:t>ball</a:t>
+            </a:r>
+            <a:endParaRPr sz="1200">
+              <a:latin typeface="Times New Roman"/>
+              <a:ea typeface="Times New Roman"/>
+              <a:cs typeface="Times New Roman"/>
+              <a:sym typeface="Times New Roman"/>
+            </a:endParaRPr>
+          </a:p>
+          <a:p>
+            <a:pPr indent="-304800" lvl="1" marL="914400" marR="0" rtl="0" algn="l">
+              <a:lnSpc>
+                <a:spcPct val="100000"/>
+              </a:lnSpc>
+              <a:spcBef>
+                <a:spcPts val="0"/>
+              </a:spcBef>
+              <a:spcAft>
+                <a:spcPts val="0"/>
+              </a:spcAft>
+              <a:buSzPts val="1200"/>
+              <a:buFont typeface="Times New Roman"/>
+              <a:buChar char="○"/>
+            </a:pPr>
+            <a:r>
+              <a:rPr b="0" i="0" lang="en-US" sz="1200" u="none" cap="none" strike="noStrike">
+                <a:solidFill>
+                  <a:srgbClr val="000000"/>
+                </a:solidFill>
+                <a:latin typeface="Times New Roman"/>
+                <a:ea typeface="Times New Roman"/>
+                <a:cs typeface="Times New Roman"/>
+                <a:sym typeface="Times New Roman"/>
+              </a:rPr>
+              <a:t>total</a:t>
+            </a:r>
+            <a:r>
+              <a:rPr lang="en-US" sz="1200">
+                <a:latin typeface="Times New Roman"/>
+                <a:ea typeface="Times New Roman"/>
+                <a:cs typeface="Times New Roman"/>
+                <a:sym typeface="Times New Roman"/>
+              </a:rPr>
+              <a:t> </a:t>
+            </a:r>
+            <a:r>
+              <a:rPr b="0" i="0" lang="en-US" sz="1200" u="none" cap="none" strike="noStrike">
+                <a:solidFill>
+                  <a:srgbClr val="000000"/>
+                </a:solidFill>
+                <a:latin typeface="Times New Roman"/>
+                <a:ea typeface="Times New Roman"/>
+                <a:cs typeface="Times New Roman"/>
+                <a:sym typeface="Times New Roman"/>
+              </a:rPr>
+              <a:t>score</a:t>
+            </a:r>
+            <a:endParaRPr sz="1200">
+              <a:latin typeface="Times New Roman"/>
+              <a:ea typeface="Times New Roman"/>
+              <a:cs typeface="Times New Roman"/>
+              <a:sym typeface="Times New Roman"/>
+            </a:endParaRPr>
+          </a:p>
+          <a:p>
+            <a:pPr indent="-304800" lvl="1" marL="914400" marR="0" rtl="0" algn="l">
+              <a:lnSpc>
+                <a:spcPct val="100000"/>
+              </a:lnSpc>
+              <a:spcBef>
+                <a:spcPts val="0"/>
+              </a:spcBef>
+              <a:spcAft>
+                <a:spcPts val="0"/>
+              </a:spcAft>
+              <a:buSzPts val="1200"/>
+              <a:buFont typeface="Times New Roman"/>
+              <a:buChar char="○"/>
+            </a:pPr>
+            <a:r>
+              <a:rPr b="0" i="0" lang="en-US" sz="1200" u="none" cap="none" strike="noStrike">
+                <a:solidFill>
+                  <a:srgbClr val="000000"/>
+                </a:solidFill>
+                <a:latin typeface="Times New Roman"/>
+                <a:ea typeface="Times New Roman"/>
+                <a:cs typeface="Times New Roman"/>
+                <a:sym typeface="Times New Roman"/>
+              </a:rPr>
+              <a:t>wick</a:t>
+            </a:r>
+            <a:r>
+              <a:rPr lang="en-US" sz="1200">
+                <a:latin typeface="Times New Roman"/>
+                <a:ea typeface="Times New Roman"/>
+                <a:cs typeface="Times New Roman"/>
+                <a:sym typeface="Times New Roman"/>
+              </a:rPr>
+              <a:t>ets</a:t>
+            </a:r>
+            <a:endParaRPr sz="1200">
+              <a:latin typeface="Times New Roman"/>
+              <a:ea typeface="Times New Roman"/>
+              <a:cs typeface="Times New Roman"/>
+              <a:sym typeface="Times New Roman"/>
+            </a:endParaRPr>
+          </a:p>
+          <a:p>
+            <a:pPr indent="-304800" lvl="1" marL="914400" marR="0" rtl="0" algn="l">
+              <a:lnSpc>
+                <a:spcPct val="100000"/>
+              </a:lnSpc>
+              <a:spcBef>
+                <a:spcPts val="0"/>
+              </a:spcBef>
+              <a:spcAft>
+                <a:spcPts val="0"/>
+              </a:spcAft>
+              <a:buSzPts val="1200"/>
+              <a:buFont typeface="Times New Roman"/>
+              <a:buChar char="○"/>
+            </a:pPr>
+            <a:r>
+              <a:rPr lang="en-US" sz="1200">
+                <a:latin typeface="Times New Roman"/>
+                <a:ea typeface="Times New Roman"/>
+                <a:cs typeface="Times New Roman"/>
+                <a:sym typeface="Times New Roman"/>
+              </a:rPr>
+              <a:t>last 5 overs score</a:t>
+            </a:r>
+            <a:endParaRPr sz="1200">
+              <a:latin typeface="Times New Roman"/>
+              <a:ea typeface="Times New Roman"/>
+              <a:cs typeface="Times New Roman"/>
+              <a:sym typeface="Times New Roman"/>
+            </a:endParaRPr>
+          </a:p>
+          <a:p>
+            <a:pPr indent="-304800" lvl="1" marL="914400" marR="0" rtl="0" algn="l">
+              <a:lnSpc>
+                <a:spcPct val="100000"/>
+              </a:lnSpc>
+              <a:spcBef>
+                <a:spcPts val="0"/>
+              </a:spcBef>
+              <a:spcAft>
+                <a:spcPts val="0"/>
+              </a:spcAft>
+              <a:buSzPts val="1200"/>
+              <a:buFont typeface="Times New Roman"/>
+              <a:buChar char="○"/>
+            </a:pPr>
+            <a:r>
+              <a:rPr lang="en-US" sz="1200">
+                <a:latin typeface="Times New Roman"/>
+                <a:ea typeface="Times New Roman"/>
+                <a:cs typeface="Times New Roman"/>
+                <a:sym typeface="Times New Roman"/>
+              </a:rPr>
+              <a:t>current run rate</a:t>
+            </a:r>
+            <a:endParaRPr sz="1200">
+              <a:latin typeface="Times New Roman"/>
+              <a:ea typeface="Times New Roman"/>
+              <a:cs typeface="Times New Roman"/>
+              <a:sym typeface="Times New Roman"/>
+            </a:endParaRPr>
+          </a:p>
+          <a:p>
+            <a:pPr indent="-304800" lvl="1" marL="914400" marR="0" rtl="0" algn="l">
+              <a:lnSpc>
+                <a:spcPct val="100000"/>
+              </a:lnSpc>
+              <a:spcBef>
+                <a:spcPts val="0"/>
+              </a:spcBef>
+              <a:spcAft>
+                <a:spcPts val="0"/>
+              </a:spcAft>
+              <a:buSzPts val="1200"/>
+              <a:buFont typeface="Times New Roman"/>
+              <a:buChar char="○"/>
+            </a:pPr>
+            <a:r>
+              <a:rPr lang="en-US" sz="1200">
+                <a:latin typeface="Times New Roman"/>
+                <a:ea typeface="Times New Roman"/>
+                <a:cs typeface="Times New Roman"/>
+                <a:sym typeface="Times New Roman"/>
+              </a:rPr>
+              <a:t>overs remaining</a:t>
+            </a:r>
+            <a:endParaRPr sz="1200">
+              <a:latin typeface="Times New Roman"/>
+              <a:ea typeface="Times New Roman"/>
+              <a:cs typeface="Times New Roman"/>
+              <a:sym typeface="Times New Roman"/>
+            </a:endParaRPr>
+          </a:p>
+          <a:p>
+            <a:pPr indent="-304800" lvl="1" marL="914400" marR="0" rtl="0" algn="l">
+              <a:lnSpc>
+                <a:spcPct val="100000"/>
+              </a:lnSpc>
+              <a:spcBef>
+                <a:spcPts val="0"/>
+              </a:spcBef>
+              <a:spcAft>
+                <a:spcPts val="0"/>
+              </a:spcAft>
+              <a:buSzPts val="1200"/>
+              <a:buFont typeface="Times New Roman"/>
+              <a:buChar char="○"/>
+            </a:pPr>
+            <a:r>
+              <a:rPr lang="en-US" sz="1200">
+                <a:latin typeface="Times New Roman"/>
+                <a:ea typeface="Times New Roman"/>
+                <a:cs typeface="Times New Roman"/>
+                <a:sym typeface="Times New Roman"/>
+              </a:rPr>
+              <a:t>last 3 overs score (short term momentum)</a:t>
+            </a:r>
+            <a:endParaRPr sz="1200">
+              <a:latin typeface="Times New Roman"/>
+              <a:ea typeface="Times New Roman"/>
+              <a:cs typeface="Times New Roman"/>
+              <a:sym typeface="Times New Roman"/>
+            </a:endParaRPr>
+          </a:p>
+          <a:p>
+            <a:pPr indent="-304800" lvl="1" marL="914400" rtl="0" algn="l">
+              <a:spcBef>
+                <a:spcPts val="0"/>
+              </a:spcBef>
+              <a:spcAft>
+                <a:spcPts val="0"/>
+              </a:spcAft>
+              <a:buSzPts val="1200"/>
+              <a:buFont typeface="Times New Roman"/>
+              <a:buChar char="○"/>
+            </a:pPr>
+            <a:r>
+              <a:rPr lang="en-US" sz="1200">
+                <a:solidFill>
+                  <a:schemeClr val="dk1"/>
+                </a:solidFill>
+                <a:latin typeface="Times New Roman"/>
+                <a:ea typeface="Times New Roman"/>
+                <a:cs typeface="Times New Roman"/>
+                <a:sym typeface="Times New Roman"/>
+              </a:rPr>
+              <a:t>last 5 overs score (medium term momentum)</a:t>
+            </a:r>
+            <a:endParaRPr sz="1200">
+              <a:latin typeface="Times New Roman"/>
+              <a:ea typeface="Times New Roman"/>
+              <a:cs typeface="Times New Roman"/>
+              <a:sym typeface="Times New Roman"/>
+            </a:endParaRPr>
+          </a:p>
+          <a:p>
+            <a:pPr indent="-304800" lvl="1" marL="914400" marR="0" rtl="0" algn="l">
+              <a:lnSpc>
+                <a:spcPct val="100000"/>
+              </a:lnSpc>
+              <a:spcBef>
+                <a:spcPts val="0"/>
+              </a:spcBef>
+              <a:spcAft>
+                <a:spcPts val="0"/>
+              </a:spcAft>
+              <a:buSzPts val="1200"/>
+              <a:buFont typeface="Times New Roman"/>
+              <a:buChar char="○"/>
+            </a:pPr>
+            <a:r>
+              <a:rPr lang="en-US" sz="1200">
+                <a:latin typeface="Times New Roman"/>
+                <a:ea typeface="Times New Roman"/>
+                <a:cs typeface="Times New Roman"/>
+                <a:sym typeface="Times New Roman"/>
+              </a:rPr>
+              <a:t>last 10 overs score (longer recent context)</a:t>
+            </a:r>
+            <a:endParaRPr sz="1200">
+              <a:latin typeface="Times New Roman"/>
+              <a:ea typeface="Times New Roman"/>
+              <a:cs typeface="Times New Roman"/>
+              <a:sym typeface="Times New Roman"/>
+            </a:endParaRPr>
+          </a:p>
+          <a:p>
+            <a:pPr indent="-304800" lvl="1" marL="914400" marR="0" rtl="0" algn="l">
+              <a:lnSpc>
+                <a:spcPct val="100000"/>
+              </a:lnSpc>
+              <a:spcBef>
+                <a:spcPts val="0"/>
+              </a:spcBef>
+              <a:spcAft>
+                <a:spcPts val="0"/>
+              </a:spcAft>
+              <a:buSzPts val="1200"/>
+              <a:buFont typeface="Times New Roman"/>
+              <a:buChar char="○"/>
+            </a:pPr>
+            <a:r>
+              <a:rPr lang="en-US" sz="1200">
+                <a:latin typeface="Times New Roman"/>
+                <a:ea typeface="Times New Roman"/>
+                <a:cs typeface="Times New Roman"/>
+                <a:sym typeface="Times New Roman"/>
+              </a:rPr>
+              <a:t>boundary rate</a:t>
+            </a:r>
+            <a:endParaRPr sz="1200">
+              <a:latin typeface="Times New Roman"/>
+              <a:ea typeface="Times New Roman"/>
+              <a:cs typeface="Times New Roman"/>
+              <a:sym typeface="Times New Roman"/>
+            </a:endParaRPr>
+          </a:p>
+          <a:p>
+            <a:pPr indent="-304800" lvl="1" marL="914400" marR="0" rtl="0" algn="l">
+              <a:lnSpc>
+                <a:spcPct val="100000"/>
+              </a:lnSpc>
+              <a:spcBef>
+                <a:spcPts val="0"/>
+              </a:spcBef>
+              <a:spcAft>
+                <a:spcPts val="0"/>
+              </a:spcAft>
+              <a:buSzPts val="1200"/>
+              <a:buFont typeface="Times New Roman"/>
+              <a:buChar char="○"/>
+            </a:pPr>
+            <a:r>
+              <a:rPr lang="en-US" sz="1200">
+                <a:latin typeface="Times New Roman"/>
+                <a:ea typeface="Times New Roman"/>
+                <a:cs typeface="Times New Roman"/>
+                <a:sym typeface="Times New Roman"/>
+              </a:rPr>
+              <a:t>dot ball rate</a:t>
+            </a:r>
+            <a:endParaRPr sz="1200">
+              <a:latin typeface="Times New Roman"/>
+              <a:ea typeface="Times New Roman"/>
+              <a:cs typeface="Times New Roman"/>
+              <a:sym typeface="Times New Roman"/>
+            </a:endParaRPr>
+          </a:p>
+          <a:p>
+            <a:pPr indent="-317500" lvl="0" marL="457200" rtl="0" algn="l">
+              <a:spcBef>
+                <a:spcPts val="0"/>
+              </a:spcBef>
+              <a:spcAft>
+                <a:spcPts val="0"/>
+              </a:spcAft>
+              <a:buSzPts val="1400"/>
+              <a:buFont typeface="Times New Roman"/>
+              <a:buChar char="●"/>
+            </a:pPr>
+            <a:r>
+              <a:rPr lang="en-US">
+                <a:solidFill>
+                  <a:schemeClr val="dk1"/>
+                </a:solidFill>
+                <a:latin typeface="Times New Roman"/>
+                <a:ea typeface="Times New Roman"/>
+                <a:cs typeface="Times New Roman"/>
+                <a:sym typeface="Times New Roman"/>
+              </a:rPr>
+              <a:t>7 categorical features: </a:t>
+            </a:r>
+            <a:endParaRPr>
+              <a:solidFill>
+                <a:schemeClr val="dk1"/>
+              </a:solidFill>
+              <a:latin typeface="Times New Roman"/>
+              <a:ea typeface="Times New Roman"/>
+              <a:cs typeface="Times New Roman"/>
+              <a:sym typeface="Times New Roman"/>
+            </a:endParaRPr>
+          </a:p>
+          <a:p>
+            <a:pPr indent="-304800" lvl="1" marL="914400" rtl="0" algn="l">
+              <a:spcBef>
+                <a:spcPts val="0"/>
+              </a:spcBef>
+              <a:spcAft>
+                <a:spcPts val="0"/>
+              </a:spcAft>
+              <a:buSzPts val="1200"/>
+              <a:buFont typeface="Times New Roman"/>
+              <a:buChar char="○"/>
+            </a:pPr>
+            <a:r>
+              <a:rPr lang="en-US" sz="1200">
+                <a:solidFill>
+                  <a:schemeClr val="dk1"/>
+                </a:solidFill>
+                <a:latin typeface="Times New Roman"/>
+                <a:ea typeface="Times New Roman"/>
+                <a:cs typeface="Times New Roman"/>
+                <a:sym typeface="Times New Roman"/>
+              </a:rPr>
+              <a:t>season, venue, batting team, bowling team, batter, non-striker and bowler.</a:t>
+            </a:r>
+            <a:endParaRPr sz="1200">
+              <a:latin typeface="Times New Roman"/>
+              <a:ea typeface="Times New Roman"/>
+              <a:cs typeface="Times New Roman"/>
+              <a:sym typeface="Times New Roman"/>
+            </a:endParaRPr>
+          </a:p>
+          <a:p>
+            <a:pPr indent="-317500" lvl="0" marL="457200" marR="0" rtl="0" algn="l">
+              <a:lnSpc>
+                <a:spcPct val="100000"/>
+              </a:lnSpc>
+              <a:spcBef>
+                <a:spcPts val="0"/>
+              </a:spcBef>
+              <a:spcAft>
+                <a:spcPts val="0"/>
+              </a:spcAft>
+              <a:buClr>
+                <a:srgbClr val="000000"/>
+              </a:buClr>
+              <a:buSzPts val="1400"/>
+              <a:buFont typeface="Times New Roman"/>
+              <a:buChar char="●"/>
+            </a:pPr>
+            <a:r>
+              <a:rPr b="0" i="0" lang="en-US" sz="1400" u="none" cap="none" strike="noStrike">
+                <a:solidFill>
+                  <a:srgbClr val="000000"/>
+                </a:solidFill>
+                <a:latin typeface="Times New Roman"/>
+                <a:ea typeface="Times New Roman"/>
+                <a:cs typeface="Times New Roman"/>
+                <a:sym typeface="Times New Roman"/>
+              </a:rPr>
+              <a:t>Temporal variables include last-3/5/10-over scoring, boundary rate, dot-ball rate and recent 5-over wickets.</a:t>
             </a:r>
             <a:endParaRPr b="0" i="0" sz="1400" u="none" cap="none" strike="noStrike">
               <a:solidFill>
@@ -8743,12 +9341,12 @@
             </a:endParaRPr>
           </a:p>
           <a:p>
-            <a:pPr indent="0" lvl="0" marL="0" marR="0" rtl="0" algn="l">
-              <a:lnSpc>
-                <a:spcPct val="100000"/>
-              </a:lnSpc>
-              <a:spcBef>
-                <a:spcPts val="700"/>
+            <a:pPr indent="-317500" lvl="0" marL="457200" marR="0" rtl="0" algn="l">
+              <a:lnSpc>
+                <a:spcPct val="100000"/>
+              </a:lnSpc>
+              <a:spcBef>
+                <a:spcPts val="0"/>
               </a:spcBef>
               <a:spcAft>
                 <a:spcPts val="0"/>
@@ -8757,8 +9355,8 @@
                 <a:srgbClr val="000000"/>
               </a:buClr>
               <a:buSzPts val="1400"/>
-              <a:buFont typeface="Arial"/>
-              <a:buNone/>
+              <a:buFont typeface="Times New Roman"/>
+              <a:buChar char="●"/>
             </a:pPr>
             <a:r>
               <a:rPr b="0" i="0" lang="en-US" sz="1400" u="none" cap="none" strike="noStrike">
@@ -8770,7 +9368,7 @@
                 <a:cs typeface="Times New Roman"/>
                 <a:sym typeface="Times New Roman"/>
               </a:rPr>
-              <a:t>• Temporal variables include last-3/5/10-over scoring, boundary rate, dot-ball rate and recent 5-over wickets.</a:t>
+              <a:t>Categorical variables are one-hot encoded with unknown categories handled safely.</a:t>
             </a:r>
             <a:endParaRPr b="0" i="0" sz="1400" u="none" cap="none" strike="noStrike">
               <a:solidFill>
@@ -8783,12 +9381,12 @@
             </a:endParaRPr>
           </a:p>
           <a:p>
-            <a:pPr indent="0" lvl="0" marL="0" marR="0" rtl="0" algn="l">
-              <a:lnSpc>
-                <a:spcPct val="100000"/>
-              </a:lnSpc>
-              <a:spcBef>
-                <a:spcPts val="700"/>
+            <a:pPr indent="-317500" lvl="0" marL="457200" marR="0" rtl="0" algn="l">
+              <a:lnSpc>
+                <a:spcPct val="100000"/>
+              </a:lnSpc>
+              <a:spcBef>
+                <a:spcPts val="0"/>
               </a:spcBef>
               <a:spcAft>
                 <a:spcPts val="0"/>
@@ -8797,8 +9395,8 @@
                 <a:srgbClr val="000000"/>
               </a:buClr>
               <a:buSzPts val="1400"/>
-              <a:buFont typeface="Arial"/>
-              <a:buNone/>
+              <a:buFont typeface="Times New Roman"/>
+              <a:buChar char="●"/>
             </a:pPr>
             <a:r>
               <a:rPr b="0" i="0" lang="en-US" sz="1400" u="none" cap="none" strike="noStrike">
@@ -8810,87 +9408,7 @@
                 <a:cs typeface="Times New Roman"/>
                 <a:sym typeface="Times New Roman"/>
               </a:rPr>
-              <a:t>• 7 categorical features: season, venue, batting team, bowling team, batter, non-striker and bowler.</a:t>
-            </a:r>
-            <a:endParaRPr b="0" i="0" sz="1400" u="none" cap="none" strike="noStrike">
-              <a:solidFill>
-                <a:srgbClr val="000000"/>
-              </a:solidFill>
-              <a:latin typeface="Arial"/>
-              <a:ea typeface="Arial"/>
-              <a:cs typeface="Arial"/>
-              <a:sym typeface="Arial"/>
-            </a:endParaRPr>
-          </a:p>
-          <a:p>
-            <a:pPr indent="0" lvl="0" marL="0" marR="0" rtl="0" algn="l">
-              <a:lnSpc>
-                <a:spcPct val="100000"/>
-              </a:lnSpc>
-              <a:spcBef>
-                <a:spcPts val="700"/>
-              </a:spcBef>
-              <a:spcAft>
-                <a:spcPts val="0"/>
-              </a:spcAft>
-              <a:buClr>
-                <a:srgbClr val="000000"/>
-              </a:buClr>
-              <a:buSzPts val="1400"/>
-              <a:buFont typeface="Arial"/>
-              <a:buNone/>
-            </a:pPr>
-            <a:r>
-              <a:rPr b="0" i="0" lang="en-US" sz="1400" u="none" cap="none" strike="noStrike">
-                <a:solidFill>
-                  <a:srgbClr val="000000"/>
-                </a:solidFill>
-                <a:latin typeface="Times New Roman"/>
-                <a:ea typeface="Times New Roman"/>
-                <a:cs typeface="Times New Roman"/>
-                <a:sym typeface="Times New Roman"/>
-              </a:rPr>
-              <a:t>• Categorical variables are one-hot encoded with unknown categories handled safely.</a:t>
-            </a:r>
-            <a:endParaRPr b="0" i="0" sz="1400" u="none" cap="none" strike="noStrike">
-              <a:solidFill>
-                <a:srgbClr val="000000"/>
-              </a:solidFill>
-              <a:latin typeface="Arial"/>
-              <a:ea typeface="Arial"/>
-              <a:cs typeface="Arial"/>
-              <a:sym typeface="Arial"/>
-            </a:endParaRPr>
-          </a:p>
-          <a:p>
-            <a:pPr indent="0" lvl="0" marL="0" marR="0" rtl="0" algn="l">
-              <a:lnSpc>
-                <a:spcPct val="100000"/>
-              </a:lnSpc>
-              <a:spcBef>
-                <a:spcPts val="700"/>
-              </a:spcBef>
-              <a:spcAft>
-                <a:spcPts val="700"/>
-              </a:spcAft>
-              <a:buClr>
-                <a:srgbClr val="000000"/>
-              </a:buClr>
-              <a:buSzPts val="1400"/>
-              <a:buFont typeface="Arial"/>
-              <a:buNone/>
-            </a:pPr>
-            <a:r>
-              <a:rPr b="0" i="0" lang="en-US" sz="1400" u="none" cap="none" strike="noStrike">
-                <a:solidFill>
-                  <a:srgbClr val="000000"/>
-                </a:solidFill>
-                <a:latin typeface="Times New Roman"/>
-                <a:ea typeface="Times New Roman"/>
-                <a:cs typeface="Times New Roman"/>
-                <a:sym typeface="Times New Roman"/>
-              </a:rPr>
-              <a:t>• Final score-prediction input size = 20 features.</a:t>
+              <a:t>Final score-prediction input size = 20 features.</a:t>
             </a:r>
             <a:endParaRPr b="0" i="0" sz="1400" u="none" cap="none" strike="noStrike">
               <a:solidFill>
@@ -10611,7 +11129,28 @@
                 <a:cs typeface="Times New Roman"/>
                 <a:sym typeface="Times New Roman"/>
               </a:rPr>
-              <a:t>• Chronological match-level split: 2,060 training matches and 516 testing matches.</a:t>
+              <a:t>• </a:t>
+            </a:r>
+            <a:r>
+              <a:rPr lang="en-US">
+                <a:latin typeface="Times New Roman"/>
+                <a:ea typeface="Times New Roman"/>
+                <a:cs typeface="Times New Roman"/>
+                <a:sym typeface="Times New Roman"/>
+              </a:rPr>
+              <a:t>Randomized match-level split</a:t>
+            </a:r>
+            <a:r>
+              <a:rPr b="0" i="0" lang="en-US" sz="1400" u="none" cap="none" strike="noStrike">
+                <a:solidFill>
+                  <a:srgbClr val="000000"/>
+                </a:solidFill>
+                <a:latin typeface="Times New Roman"/>
+                <a:ea typeface="Times New Roman"/>
+                <a:cs typeface="Times New Roman"/>
+                <a:sym typeface="Times New Roman"/>
+              </a:rPr>
+              <a:t>: 2,060 training matches and 516 testing matches.</a:t>
             </a:r>
             <a:endParaRPr b="0" i="0" sz="1400" u="none" cap="none" strike="noStrike">
               <a:solidFill>
@@ -11317,7 +11856,7 @@
             <a:tbl>
               <a:tblPr bandRow="1" firstRow="1">
                 <a:noFill/>
-                <a:tableStyleId>{849E72A2-204A-4A87-8C0E-7DC628C7B589}</a:tableStyleId>
+                <a:tableStyleId>{56352577-8086-43E6-AA43-89DAD8EF78DC}</a:tableStyleId>
               </a:tblPr>
               <a:tblGrid>
                 <a:gridCol w="3566150"/>
@@ -12762,7 +13301,7 @@
           </a:bodyPr>
           <a:lstStyle/>
           <a:p>
-            <a:pPr indent="-241300" lvl="0" marL="228600" marR="0" rtl="0" algn="just">
+            <a:pPr indent="-228600" lvl="0" marL="228600" marR="0" rtl="0" algn="just">
               <a:lnSpc>
                 <a:spcPct val="150000"/>
               </a:lnSpc>
@@ -12780,7 +13319,7 @@
               <a:buAutoNum type="arabicPeriod"/>
             </a:pPr>
             <a:r>
-              <a:rPr b="0" i="0" lang="en-US" u="none" cap="none" strike="noStrike">
+              <a:rPr b="0" i="0" lang="en-US" sz="1400" u="none" cap="none" strike="noStrike">
                 <a:solidFill>
                   <a:srgbClr val="000000"/>
                 </a:solidFill>
@@ -12802,7 +13341,7 @@
             </a:endParaRPr>
           </a:p>
           <a:p>
-            <a:pPr indent="-241300" lvl="0" marL="228600" marR="0" rtl="0" algn="just">
+            <a:pPr indent="-228600" lvl="0" marL="228600" marR="0" rtl="0" algn="just">
               <a:lnSpc>
                 <a:spcPct val="150000"/>
               </a:lnSpc>
@@ -12820,7 +13359,7 @@
               <a:buAutoNum type="arabicPeriod"/>
             </a:pPr>
             <a:r>
-              <a:rPr b="0" i="0" lang="en-US" u="none" cap="none" strike="noStrike">
+              <a:rPr b="0" i="0" lang="en-US" sz="1400" u="none" cap="none" strike="noStrike">
                 <a:solidFill>
                   <a:srgbClr val="000000"/>
                 </a:solidFill>
@@ -12842,7 +13381,7 @@
             </a:endParaRPr>
           </a:p>
           <a:p>
-            <a:pPr indent="-241300" lvl="0" marL="228600" marR="0" rtl="0" algn="just">
+            <a:pPr indent="-228600" lvl="0" marL="228600" marR="0" rtl="0" algn="just">
               <a:lnSpc>
                 <a:spcPct val="150000"/>
               </a:lnSpc>
@@ -12860,7 +13399,7 @@
               <a:buAutoNum type="arabicPeriod"/>
             </a:pPr>
             <a:r>
-              <a:rPr b="0" i="0" lang="en-US" u="none" cap="none" strike="noStrike">
+              <a:rPr b="0" i="0" lang="en-US" sz="1400" u="none" cap="none" strike="noStrike">
                 <a:solidFill>
                   <a:srgbClr val="000000"/>
                 </a:solidFill>
@@ -12882,7 +13421,7 @@
             </a:endParaRPr>
           </a:p>
           <a:p>
-            <a:pPr indent="-241300" lvl="0" marL="228600" marR="0" rtl="0" algn="just">
+            <a:pPr indent="-228600" lvl="0" marL="228600" marR="0" rtl="0" algn="just">
               <a:lnSpc>
                 <a:spcPct val="150000"/>
               </a:lnSpc>
@@ -12900,7 +13439,7 @@
               <a:buAutoNum type="arabicPeriod"/>
             </a:pPr>
             <a:r>
-              <a:rPr b="0" i="0" lang="en-US" u="none" cap="none" strike="noStrike">
+              <a:rPr b="0" i="0" lang="en-US" sz="1400" u="none" cap="none" strike="noStrike">
                 <a:solidFill>
                   <a:srgbClr val="000000"/>
                 </a:solidFill>
@@ -12922,7 +13461,7 @@
             </a:endParaRPr>
           </a:p>
           <a:p>
-            <a:pPr indent="-241300" lvl="0" marL="228600" marR="0" rtl="0" algn="just">
+            <a:pPr indent="-228600" lvl="0" marL="228600" marR="0" rtl="0" algn="just">
               <a:lnSpc>
                 <a:spcPct val="150000"/>
               </a:lnSpc>
@@ -12940,7 +13479,7 @@
               <a:buAutoNum type="arabicPeriod"/>
             </a:pPr>
             <a:r>
-              <a:rPr b="0" i="0" lang="en-US" u="none" cap="none" strike="noStrike">
+              <a:rPr b="0" i="0" lang="en-US" sz="1400" u="none" cap="none" strike="noStrike">
                 <a:solidFill>
                   <a:srgbClr val="000000"/>
                 </a:solidFill>
@@ -12962,7 +13501,7 @@
             </a:endParaRPr>
           </a:p>
           <a:p>
-            <a:pPr indent="-241300" lvl="0" marL="228600" marR="0" rtl="0" algn="just">
+            <a:pPr indent="-228600" lvl="0" marL="228600" marR="0" rtl="0" algn="just">
               <a:lnSpc>
                 <a:spcPct val="150000"/>
               </a:lnSpc>
@@ -12980,7 +13519,7 @@
               <a:buAutoNum type="arabicPeriod"/>
             </a:pPr>
             <a:r>
-              <a:rPr b="0" i="0" lang="en-US" u="none" cap="none" strike="noStrike">
+              <a:rPr b="0" i="0" lang="en-US" sz="1400" u="none" cap="none" strike="noStrike">
                 <a:solidFill>
                   <a:srgbClr val="000000"/>
                 </a:solidFill>
@@ -13002,7 +13541,7 @@
             </a:endParaRPr>
           </a:p>
           <a:p>
-            <a:pPr indent="-241300" lvl="0" marL="228600" marR="0" rtl="0" algn="just">
+            <a:pPr indent="-228600" lvl="0" marL="228600" marR="0" rtl="0" algn="just">
               <a:lnSpc>
                 <a:spcPct val="150000"/>
               </a:lnSpc>
@@ -13020,7 +13559,7 @@
               <a:buAutoNum type="arabicPeriod"/>
             </a:pPr>
             <a:r>
-              <a:rPr b="0" i="0" lang="en-US" u="none" cap="none" strike="noStrike">
+              <a:rPr b="0" i="0" lang="en-US" sz="1400" u="none" cap="none" strike="noStrike">
                 <a:solidFill>
                   <a:srgbClr val="000000"/>
                 </a:solidFill>
@@ -13042,7 +13581,7 @@
             </a:endParaRPr>
           </a:p>
           <a:p>
-            <a:pPr indent="-241300" lvl="0" marL="228600" marR="0" rtl="0" algn="just">
+            <a:pPr indent="-228600" lvl="0" marL="228600" marR="0" rtl="0" algn="just">
               <a:lnSpc>
                 <a:spcPct val="150000"/>
               </a:lnSpc>
@@ -13060,7 +13599,7 @@
               <a:buAutoNum type="arabicPeriod"/>
             </a:pPr>
             <a:r>
-              <a:rPr b="0" i="0" lang="en-US" u="none" cap="none" strike="noStrike">
+              <a:rPr b="0" i="0" lang="en-US" sz="1400" u="none" cap="none" strike="noStrike">
                 <a:solidFill>
                   <a:srgbClr val="000000"/>
                 </a:solidFill>
@@ -13082,7 +13621,7 @@
             </a:endParaRPr>
           </a:p>
           <a:p>
-            <a:pPr indent="-241300" lvl="0" marL="228600" marR="0" rtl="0" algn="just">
+            <a:pPr indent="-228600" lvl="0" marL="228600" marR="0" rtl="0" algn="just">
               <a:lnSpc>
                 <a:spcPct val="150000"/>
               </a:lnSpc>
@@ -13100,7 +13639,10 @@
               <a:buAutoNum type="arabicPeriod"/>
             </a:pPr>
             <a:r>
-              <a:rPr lang="en-US">
+              <a:rPr b="0" i="0" lang="en-US" sz="1400" u="none" cap="none" strike="noStrike">
+                <a:solidFill>
+                  <a:srgbClr val="000000"/>
+                </a:solidFill>
                 <a:latin typeface="Times New Roman"/>
                 <a:ea typeface="Times New Roman"/>
                 <a:cs typeface="Times New Roman"/>
@@ -13119,7 +13661,7 @@
             </a:endParaRPr>
           </a:p>
           <a:p>
-            <a:pPr indent="-241300" lvl="0" marL="228600" marR="0" rtl="0" algn="just">
+            <a:pPr indent="-228600" lvl="0" marL="228600" marR="0" rtl="0" algn="just">
               <a:lnSpc>
                 <a:spcPct val="150000"/>
               </a:lnSpc>
@@ -13137,7 +13679,7 @@
               <a:buAutoNum type="arabicPeriod"/>
             </a:pPr>
             <a:r>
-              <a:rPr b="0" i="0" lang="en-US" u="none" cap="none" strike="noStrike">
+              <a:rPr b="0" i="0" lang="en-US" sz="1400" u="none" cap="none" strike="noStrike">
                 <a:solidFill>
                   <a:srgbClr val="000000"/>
                 </a:solidFill>
@@ -14316,12 +14858,18 @@
               <a:spcAft>
                 <a:spcPts val="0"/>
               </a:spcAft>
+              <a:buClr>
+                <a:srgbClr val="000000"/>
+              </a:buClr>
               <a:buSzPts val="1400"/>
               <a:buFont typeface="Times New Roman"/>
               <a:buAutoNum type="arabicPeriod"/>
             </a:pPr>
             <a:r>
-              <a:rPr lang="en-US">
+              <a:rPr b="0" i="0" lang="en-US" sz="1400" u="none" cap="none" strike="noStrike">
+                <a:solidFill>
+                  <a:srgbClr val="000000"/>
+                </a:solidFill>
                 <a:latin typeface="Times New Roman"/>
                 <a:ea typeface="Times New Roman"/>
                 <a:cs typeface="Times New Roman"/>
@@ -14329,7 +14877,10 @@
               </a:rPr>
               <a:t>Suguna R., Praveen Kumar Y., Suriya Prakash J., Neethu P.S., and Kiran S., “Utilizing Machine Learning for Sport Data Analytics in Cricket: Score Prediction and Player Categorization,” 2023 IEEE 3rd Mysore Sub Section International Conference (MysuruCon), 2023. </a:t>
             </a:r>
-            <a:endParaRPr>
+            <a:endParaRPr b="0" i="0" sz="1400" u="none" cap="none" strike="noStrike">
+              <a:solidFill>
+                <a:srgbClr val="000000"/>
+              </a:solidFill>
               <a:latin typeface="Times New Roman"/>
               <a:ea typeface="Times New Roman"/>
               <a:cs typeface="Times New Roman"/>
@@ -14347,12 +14898,18 @@
               <a:spcAft>
                 <a:spcPts val="0"/>
               </a:spcAft>
+              <a:buClr>
+                <a:srgbClr val="000000"/>
+              </a:buClr>
               <a:buSzPts val="1400"/>
               <a:buFont typeface="Times New Roman"/>
               <a:buAutoNum type="arabicPeriod"/>
             </a:pPr>
             <a:r>
-              <a:rPr lang="en-US">
+              <a:rPr b="0" i="0" lang="en-US" sz="1400" u="none" cap="none" strike="noStrike">
+                <a:solidFill>
+                  <a:srgbClr val="000000"/>
+                </a:solidFill>
                 <a:latin typeface="Times New Roman"/>
                 <a:ea typeface="Times New Roman"/>
                 <a:cs typeface="Times New Roman"/>
@@ -14360,7 +14917,10 @@
               </a:rPr>
               <a:t>S. Gagana, "A Perspective on Analyzing IPL Match Results using Machine Learning," Int. J. for Sci. Research &amp; Development, vol. 7, no. 3, pp. 1476-1479, 2019. </a:t>
             </a:r>
-            <a:endParaRPr>
+            <a:endParaRPr b="0" i="0" sz="1400" u="none" cap="none" strike="noStrike">
+              <a:solidFill>
+                <a:srgbClr val="000000"/>
+              </a:solidFill>
               <a:latin typeface="Times New Roman"/>
               <a:ea typeface="Times New Roman"/>
               <a:cs typeface="Times New Roman"/>
@@ -14378,12 +14938,18 @@
               <a:spcAft>
                 <a:spcPts val="0"/>
               </a:spcAft>
+              <a:buClr>
+                <a:srgbClr val="000000"/>
+              </a:buClr>
               <a:buSzPts val="1400"/>
               <a:buFont typeface="Times New Roman"/>
               <a:buAutoNum type="arabicPeriod"/>
             </a:pPr>
             <a:r>
-              <a:rPr lang="en-US">
+              <a:rPr b="0" i="0" lang="en-US" sz="1400" u="none" cap="none" strike="noStrike">
+                <a:solidFill>
+                  <a:srgbClr val="000000"/>
+                </a:solidFill>
                 <a:latin typeface="Times New Roman"/>
                 <a:ea typeface="Times New Roman"/>
                 <a:cs typeface="Times New Roman"/>
@@ -14391,7 +14957,10 @@
               </a:rPr>
               <a:t>A. Lawate et al., "Cricket Analysis and Prediction of projected Score and Winner using Machine Learning," Int. J. of Adv. Research in Computer and Comm. Engg., vol. 10, no. 2, 2021. </a:t>
             </a:r>
-            <a:endParaRPr>
+            <a:endParaRPr b="0" i="0" sz="1400" u="none" cap="none" strike="noStrike">
+              <a:solidFill>
+                <a:srgbClr val="000000"/>
+              </a:solidFill>
               <a:latin typeface="Times New Roman"/>
               <a:ea typeface="Times New Roman"/>
               <a:cs typeface="Times New Roman"/>
@@ -16996,7 +17565,7 @@
             <a:tbl>
               <a:tblPr bandRow="1" firstRow="1">
                 <a:noFill/>
-                <a:tableStyleId>{849E72A2-204A-4A87-8C0E-7DC628C7B589}</a:tableStyleId>
+                <a:tableStyleId>{56352577-8086-43E6-AA43-89DAD8EF78DC}</a:tableStyleId>
               </a:tblPr>
               <a:tblGrid>
                 <a:gridCol w="2162675"/>
@@ -17055,10 +17624,15 @@
                         <a:spcAft>
                           <a:spcPts val="0"/>
                         </a:spcAft>
+                        <a:buClr>
+                          <a:srgbClr val="000000"/>
+                        </a:buClr>
+                        <a:buSzPts val="1250"/>
+                        <a:buFont typeface="Arial"/>
                         <a:buNone/>
                       </a:pPr>
                       <a:r>
-                        <a:rPr lang="en-US" sz="1250">
+                        <a:rPr lang="en-US" sz="1250" u="none" cap="none" strike="noStrike">
                           <a:latin typeface="Times New Roman"/>
                           <a:ea typeface="Times New Roman"/>
                           <a:cs typeface="Times New Roman"/>
@@ -17137,7 +17711,7 @@
                         <a:buNone/>
                       </a:pPr>
                       <a:r>
-                        <a:rPr lang="en-US" sz="1150">
+                        <a:rPr lang="en-US" sz="1150" u="none" cap="none" strike="noStrike">
                           <a:latin typeface="Times New Roman"/>
                           <a:ea typeface="Times New Roman"/>
                           <a:cs typeface="Times New Roman"/>
@@ -17165,10 +17739,15 @@
                         <a:spcAft>
                           <a:spcPts val="0"/>
                         </a:spcAft>
+                        <a:buClr>
+                          <a:srgbClr val="000000"/>
+                        </a:buClr>
+                        <a:buSzPts val="1150"/>
+                        <a:buFont typeface="Arial"/>
                         <a:buNone/>
                       </a:pPr>
                       <a:r>
-                        <a:rPr lang="en-US" sz="1150">
+                        <a:rPr lang="en-US" sz="1150" u="none" cap="none" strike="noStrike">
                           <a:latin typeface="Times New Roman"/>
                           <a:ea typeface="Times New Roman"/>
                           <a:cs typeface="Times New Roman"/>
@@ -17176,7 +17755,7 @@
                         </a:rPr>
                         <a:t>Cricsheet ODI + ML models </a:t>
                       </a:r>
-                      <a:endParaRPr sz="1150">
+                      <a:endParaRPr sz="1150" u="none" cap="none" strike="noStrike">
                         <a:latin typeface="Times New Roman"/>
                         <a:ea typeface="Times New Roman"/>
                         <a:cs typeface="Times New Roman"/>
@@ -17209,7 +17788,7 @@
                         <a:buNone/>
                       </a:pPr>
                       <a:r>
-                        <a:rPr lang="en-US" sz="1150">
+                        <a:rPr lang="en-US" sz="1150" u="none" cap="none" strike="noStrike">
                           <a:latin typeface="Times New Roman"/>
                           <a:ea typeface="Times New Roman"/>
                           <a:cs typeface="Times New Roman"/>
@@ -17247,7 +17826,7 @@
                         <a:buNone/>
                       </a:pPr>
                       <a:r>
-                        <a:rPr lang="en-US" sz="1150">
+                        <a:rPr lang="en-US" sz="1150" u="none" cap="none" strike="noStrike">
                           <a:latin typeface="Times New Roman"/>
                           <a:ea typeface="Times New Roman"/>
                           <a:cs typeface="Times New Roman"/>
@@ -17275,10 +17854,15 @@
                         <a:spcAft>
                           <a:spcPts val="0"/>
                         </a:spcAft>
+                        <a:buClr>
+                          <a:srgbClr val="000000"/>
+                        </a:buClr>
+                        <a:buSzPts val="1150"/>
+                        <a:buFont typeface="Arial"/>
                         <a:buNone/>
                       </a:pPr>
                       <a:r>
-                        <a:rPr lang="en-US" sz="1150">
+                        <a:rPr lang="en-US" sz="1150" u="none" cap="none" strike="noStrike">
                           <a:latin typeface="Times New Roman"/>
                           <a:ea typeface="Times New Roman"/>
                           <a:cs typeface="Times New Roman"/>
@@ -17286,7 +17870,7 @@
                         </a:rPr>
                         <a:t>IPL ball-by-ball data </a:t>
                       </a:r>
-                      <a:endParaRPr sz="1150">
+                      <a:endParaRPr sz="1150" u="none" cap="none" strike="noStrike">
                         <a:latin typeface="Times New Roman"/>
                         <a:ea typeface="Times New Roman"/>
                         <a:cs typeface="Times New Roman"/>
@@ -17319,7 +17903,7 @@
                         <a:buNone/>
                       </a:pPr>
                       <a:r>
-                        <a:rPr lang="en-US" sz="1150">
+                        <a:rPr lang="en-US" sz="1150" u="none" cap="none" strike="noStrike">
                           <a:latin typeface="Times New Roman"/>
                           <a:ea typeface="Times New Roman"/>
                           <a:cs typeface="Times New Roman"/>
@@ -17357,7 +17941,7 @@
                         <a:buNone/>
                       </a:pPr>
                       <a:r>
-                        <a:rPr lang="en-US" sz="1150">
+                        <a:rPr lang="en-US" sz="1150" u="none" cap="none" strike="noStrike">
                           <a:latin typeface="Times New Roman"/>
                           <a:ea typeface="Times New Roman"/>
                           <a:cs typeface="Times New Roman"/>
@@ -17385,10 +17969,15 @@
                         <a:spcAft>
                           <a:spcPts val="0"/>
                         </a:spcAft>
+                        <a:buClr>
+                          <a:srgbClr val="000000"/>
+                        </a:buClr>
+                        <a:buSzPts val="1150"/>
+                        <a:buFont typeface="Arial"/>
                         <a:buNone/>
                       </a:pPr>
                       <a:r>
-                        <a:rPr lang="en-US" sz="1150">
+                        <a:rPr lang="en-US" sz="1150" u="none" cap="none" strike="noStrike">
                           <a:latin typeface="Times New Roman"/>
                           <a:ea typeface="Times New Roman"/>
                           <a:cs typeface="Times New Roman"/>
@@ -17396,7 +17985,7 @@
                         </a:rPr>
                         <a:t>T20 match data </a:t>
                       </a:r>
-                      <a:endParaRPr sz="1150">
+                      <a:endParaRPr sz="1150" u="none" cap="none" strike="noStrike">
                         <a:latin typeface="Times New Roman"/>
                         <a:ea typeface="Times New Roman"/>
                         <a:cs typeface="Times New Roman"/>
@@ -17429,7 +18018,7 @@
                         <a:buNone/>
                       </a:pPr>
                       <a:r>
-                        <a:rPr lang="en-US" sz="1150">
+                        <a:rPr lang="en-US" sz="1150" u="none" cap="none" strike="noStrike">
                           <a:latin typeface="Times New Roman"/>
                           <a:ea typeface="Times New Roman"/>
                           <a:cs typeface="Times New Roman"/>
@@ -17733,7 +18322,7 @@
             <a:tbl>
               <a:tblPr bandRow="1" firstRow="1">
                 <a:noFill/>
-                <a:tableStyleId>{849E72A2-204A-4A87-8C0E-7DC628C7B589}</a:tableStyleId>
+                <a:tableStyleId>{56352577-8086-43E6-AA43-89DAD8EF78DC}</a:tableStyleId>
               </a:tblPr>
               <a:tblGrid>
                 <a:gridCol w="4229100"/>
@@ -18254,13 +18843,12 @@
           <p:cNvPicPr preferRelativeResize="0"/>
           <p:nvPr/>
         </p:nvPicPr>
-        <p:blipFill>
+        <p:blipFill rotWithShape="1">
           <a:blip r:embed="rId4">
             <a:alphaModFix/>
           </a:blip>
-          <a:stretch>
-            <a:fillRect/>
-          </a:stretch>
+          <a:srcRect b="0" l="0" r="0" t="0"/>
+          <a:stretch/>
         </p:blipFill>
         <p:spPr>
           <a:xfrm>
@@ -18768,6 +19356,285 @@
 </file>
 
 <file path=ppt/theme/theme1.xml><?xml version="1.0" encoding="utf-8"?>
+<a:theme xmlns:a="http://schemas.openxmlformats.org/drawingml/2006/main" xmlns:r="http://schemas.openxmlformats.org/officeDocument/2006/relationships">
+  <a:themeElements>
+    <a:clrScheme name="Default">
+      <a:dk1>
+        <a:srgbClr val="000000"/>
+      </a:dk1>
+      <a:lt1>
+        <a:srgbClr val="FFFFFF"/>
+      </a:lt1>
+      <a:dk2>
+        <a:srgbClr val="158158"/>
+      </a:dk2>
+      <a:lt2>
+        <a:srgbClr val="F3F3F3"/>
+      </a:lt2>
+      <a:accent1>
+        <a:srgbClr val="058DC7"/>
+      </a:accent1>
+      <a:accent2>
+        <a:srgbClr val="50B432"/>
+      </a:accent2>
+      <a:accent3>
+        <a:srgbClr val="ED561B"/>
+      </a:accent3>
+      <a:accent4>
+        <a:srgbClr val="EDEF00"/>
+      </a:accent4>
+      <a:accent5>
+        <a:srgbClr val="24CBE5"/>
+      </a:accent5>
+      <a:accent6>
+        <a:srgbClr val="64E572"/>
+      </a:accent6>
+      <a:hlink>
+        <a:srgbClr val="2200CC"/>
+      </a:hlink>
+      <a:folHlink>
+        <a:srgbClr val="551A8B"/>
+      </a:folHlink>
+    </a:clrScheme>
+    <a:fontScheme name="Office">
+      <a:majorFont>
+        <a:latin typeface="Arial"/>
+        <a:ea typeface=""/>
+        <a:cs typeface=""/>
+        <a:font script="Jpan" typeface="ＭＳ Ｐゴシック"/>
+        <a:font script="Hang" typeface="맑은 고딕"/>
+        <a:font script="Hans" typeface="宋体"/>
+        <a:font script="Hant" typeface="新細明體"/>
+        <a:font script="Arab" typeface="Times New Roman"/>
+        <a:font script="Hebr" typeface="Times New Roman"/>
+        <a:font script="Thai" typeface="Angsana New"/>
+        <a:font script="Ethi" typeface="Nyala"/>
+        <a:font script="Beng" typeface="Vrinda"/>
+        <a:font script="Gujr" typeface="Shruti"/>
+        <a:font script="Khmr" typeface="MoolBoran"/>
+        <a:font script="Knda" typeface="Tunga"/>
+        <a:font script="Guru" typeface="Raavi"/>
+        <a:font script="Cans" typeface="Euphemia"/>
+        <a:font script="Cher" typeface="Plantagenet Cherokee"/>
+        <a:font script="Yiii" typeface="Microsoft Yi Baiti"/>
+        <a:font script="Tibt" typeface="Microsoft Himalaya"/>
+        <a:font script="Thaa" typeface="MV Boli"/>
+        <a:font script="Deva" typeface="Mangal"/>
+        <a:font script="Telu" typeface="Gautami"/>
+        <a:font script="Taml" typeface="Latha"/>
+        <a:font script="Syrc" typeface="Estrangelo Edessa"/>
+        <a:font script="Orya" typeface="Kalinga"/>
+        <a:font script="Mlym" typeface="Kartika"/>
+        <a:font script="Laoo" typeface="DokChampa"/>
+        <a:font script="Sinh" typeface="Iskoola Pota"/>
+        <a:font script="Mong" typeface="Mongolian Baiti"/>
+        <a:font script="Viet" typeface="Times New Roman"/>
+        <a:font script="Uigh" typeface="Microsoft Uighur"/>
+        <a:font script="Geor" typeface="Sylfaen"/>
+      </a:majorFont>
+      <a:minorFont>
+        <a:latin typeface="Arial"/>
+        <a:ea typeface=""/>
+        <a:cs typeface=""/>
+        <a:font script="Jpan" typeface="ＭＳ Ｐゴシック"/>
+        <a:font script="Hang" typeface="맑은 고딕"/>
+        <a:font script="Hans" typeface="宋体"/>
+        <a:font script="Hant" typeface="新細明體"/>
+        <a:font script="Arab" typeface="Arial"/>
+        <a:font script="Hebr" typeface="Arial"/>
+        <a:font script="Thai" typeface="Cordia New"/>
+        <a:font script="Ethi" typeface="Nyala"/>
+        <a:font script="Beng" typeface="Vrinda"/>
+        <a:font script="Gujr" typeface="Shruti"/>
+        <a:font script="Khmr" typeface="DaunPenh"/>
+        <a:font script="Knda" typeface="Tunga"/>
+        <a:font script="Guru" typeface="Raavi"/>
+        <a:font script="Cans" typeface="Euphemia"/>
+        <a:font script="Cher" typeface="Plantagenet Cherokee"/>
+        <a:font script="Yiii" typeface="Microsoft Yi Baiti"/>
+        <a:font script="Tibt" typeface="Microsoft Himalaya"/>
+        <a:font script="Thaa" typeface="MV Boli"/>
+        <a:font script="Deva" typeface="Mangal"/>
+        <a:font script="Telu" typeface="Gautami"/>
+        <a:font script="Taml" typeface="Latha"/>
+        <a:font script="Syrc" typeface="Estrangelo Edessa"/>
+        <a:font script="Orya" typeface="Kalinga"/>
+        <a:font script="Mlym" typeface="Kartika"/>
+        <a:font script="Laoo" typeface="DokChampa"/>
+        <a:font script="Sinh" typeface="Iskoola Pota"/>
+        <a:font script="Mong" typeface="Mongolian Baiti"/>
+        <a:font script="Viet" typeface="Arial"/>
+        <a:font script="Uigh" typeface="Microsoft Uighur"/>
+        <a:font script="Geor" typeface="Sylfaen"/>
+      </a:minorFont>
+    </a:fontScheme>
+    <a:fmtScheme name="Office">
+      <a:fillStyleLst>
+        <a:solidFill>
+          <a:schemeClr val="phClr"/>
+        </a:solidFill>
+        <a:gradFill rotWithShape="1">
+          <a:gsLst>
+            <a:gs pos="0">
+              <a:schemeClr val="phClr">
+                <a:tint val="50000"/>
+                <a:satMod val="300000"/>
+              </a:schemeClr>
+            </a:gs>
+            <a:gs pos="35000">
+              <a:schemeClr val="phClr">
+                <a:tint val="37000"/>
+                <a:satMod val="300000"/>
+              </a:schemeClr>
+            </a:gs>
+            <a:gs pos="100000">
+              <a:schemeClr val="phClr">
+                <a:tint val="15000"/>
+                <a:satMod val="350000"/>
+              </a:schemeClr>
+            </a:gs>
+          </a:gsLst>
+          <a:lin ang="16200000" scaled="1"/>
+        </a:gradFill>
+        <a:gradFill rotWithShape="1">
+          <a:gsLst>
+            <a:gs pos="0">
+              <a:schemeClr val="phClr">
+                <a:tint val="100000"/>
+                <a:shade val="100000"/>
+                <a:satMod val="130000"/>
+              </a:schemeClr>
+            </a:gs>
+            <a:gs pos="100000">
+              <a:schemeClr val="phClr">
+                <a:tint val="50000"/>
+                <a:shade val="100000"/>
+                <a:satMod val="350000"/>
+              </a:schemeClr>
+            </a:gs>
+          </a:gsLst>
+          <a:lin ang="16200000" scaled="0"/>
+        </a:gradFill>
+      </a:fillStyleLst>
+      <a:lnStyleLst>
+        <a:ln w="9525" cap="flat" cmpd="sng" algn="ctr">
+          <a:solidFill>
+            <a:schemeClr val="phClr">
+              <a:shade val="95000"/>
+              <a:satMod val="105000"/>
+            </a:schemeClr>
+          </a:solidFill>
+          <a:prstDash val="solid"/>
+        </a:ln>
+        <a:ln w="25400" cap="flat" cmpd="sng" algn="ctr">
+          <a:solidFill>
+            <a:schemeClr val="phClr"/>
+          </a:solidFill>
+          <a:prstDash val="solid"/>
+        </a:ln>
+        <a:ln w="38100" cap="flat" cmpd="sng" algn="ctr">
+          <a:solidFill>
+            <a:schemeClr val="phClr"/>
+          </a:solidFill>
+          <a:prstDash val="solid"/>
+        </a:ln>
+      </a:lnStyleLst>
+      <a:effectStyleLst>
+        <a:effectStyle>
+          <a:effectLst>
+            <a:outerShdw blurRad="40000" dist="20000" dir="5400000" rotWithShape="0">
+              <a:srgbClr val="000000">
+                <a:alpha val="38000"/>
+              </a:srgbClr>
+            </a:outerShdw>
+          </a:effectLst>
+        </a:effectStyle>
+        <a:effectStyle>
+          <a:effectLst>
+            <a:outerShdw blurRad="40000" dist="23000" dir="5400000" rotWithShape="0">
+              <a:srgbClr val="000000">
+                <a:alpha val="35000"/>
+              </a:srgbClr>
+            </a:outerShdw>
+          </a:effectLst>
+        </a:effectStyle>
+        <a:effectStyle>
+          <a:effectLst>
+            <a:outerShdw blurRad="40000" dist="23000" dir="5400000" rotWithShape="0">
+              <a:srgbClr val="000000">
+                <a:alpha val="35000"/>
+              </a:srgbClr>
+            </a:outerShdw>
+          </a:effectLst>
+          <a:scene3d>
+            <a:camera prst="orthographicFront">
+              <a:rot lat="0" lon="0" rev="0"/>
+            </a:camera>
+            <a:lightRig rig="threePt" dir="t">
+              <a:rot lat="0" lon="0" rev="1200000"/>
+            </a:lightRig>
+          </a:scene3d>
+          <a:sp3d>
+            <a:bevelT w="63500" h="25400"/>
+          </a:sp3d>
+        </a:effectStyle>
+      </a:effectStyleLst>
+      <a:bgFillStyleLst>
+        <a:solidFill>
+          <a:schemeClr val="phClr"/>
+        </a:solidFill>
+        <a:gradFill rotWithShape="1">
+          <a:gsLst>
+            <a:gs pos="0">
+              <a:schemeClr val="phClr">
+                <a:tint val="40000"/>
+                <a:satMod val="350000"/>
+              </a:schemeClr>
+            </a:gs>
+            <a:gs pos="40000">
+              <a:schemeClr val="phClr">
+                <a:tint val="45000"/>
+                <a:shade val="99000"/>
+                <a:satMod val="350000"/>
+              </a:schemeClr>
+            </a:gs>
+            <a:gs pos="100000">
+              <a:schemeClr val="phClr">
+                <a:shade val="20000"/>
+                <a:satMod val="255000"/>
+              </a:schemeClr>
+            </a:gs>
+          </a:gsLst>
+          <a:path path="circle">
+            <a:fillToRect l="50000" t="-80000" r="50000" b="180000"/>
+          </a:path>
+        </a:gradFill>
+        <a:gradFill rotWithShape="1">
+          <a:gsLst>
+            <a:gs pos="0">
+              <a:schemeClr val="phClr">
+                <a:tint val="80000"/>
+                <a:satMod val="300000"/>
+              </a:schemeClr>
+            </a:gs>
+            <a:gs pos="100000">
+              <a:schemeClr val="phClr">
+                <a:shade val="30000"/>
+                <a:satMod val="200000"/>
+              </a:schemeClr>
+            </a:gs>
+          </a:gsLst>
+          <a:path path="circle">
+            <a:fillToRect l="50000" t="50000" r="50000" b="50000"/>
+          </a:path>
+        </a:gradFill>
+      </a:bgFillStyleLst>
+    </a:fmtScheme>
+  </a:themeElements>
+</a:theme>
+</file>
+
+<file path=ppt/theme/theme2.xml><?xml version="1.0" encoding="utf-8"?>
 <a:theme xmlns:a="http://schemas.openxmlformats.org/drawingml/2006/main" xmlns:r="http://schemas.openxmlformats.org/officeDocument/2006/relationships" name="Default Design">
   <a:themeElements>
     <a:clrScheme name="Default Design 1">
@@ -19044,283 +19911,4 @@
     </a:fmtScheme>
   </a:themeElements>
 </a:theme>
-</file>
-
-<file path=ppt/theme/theme2.xml><?xml version="1.0" encoding="utf-8"?>
-<a:theme xmlns:a="http://schemas.openxmlformats.org/drawingml/2006/main" xmlns:r="http://schemas.openxmlformats.org/officeDocument/2006/relationships">
-  <a:themeElements>
-    <a:clrScheme name="Default">
-      <a:dk1>
-        <a:srgbClr val="000000"/>
-      </a:dk1>
-      <a:lt1>
-        <a:srgbClr val="FFFFFF"/>
-      </a:lt1>
-      <a:dk2>
-        <a:srgbClr val="158158"/>
-      </a:dk2>
-      <a:lt2>
-        <a:srgbClr val="F3F3F3"/>
-      </a:lt2>
-      <a:accent1>
-        <a:srgbClr val="058DC7"/>
-      </a:accent1>
-      <a:accent2>
-        <a:srgbClr val="50B432"/>
-      </a:accent2>
-      <a:accent3>
-        <a:srgbClr val="ED561B"/>
-      </a:accent3>
-      <a:accent4>
-        <a:srgbClr val="EDEF00"/>
-      </a:accent4>
-      <a:accent5>
-        <a:srgbClr val="24CBE5"/>
-      </a:accent5>
-      <a:accent6>
-        <a:srgbClr val="64E572"/>
-      </a:accent6>
-      <a:hlink>
-        <a:srgbClr val="2200CC"/>
-      </a:hlink>
-      <a:folHlink>
-        <a:srgbClr val="551A8B"/>
-      </a:folHlink>
-    </a:clrScheme>
-    <a:fontScheme name="Office">
-      <a:majorFont>
-        <a:latin typeface="Arial"/>
-        <a:ea typeface=""/>
-        <a:cs typeface=""/>
-        <a:font script="Jpan" typeface="ＭＳ Ｐゴシック"/>
-        <a:font script="Hang" typeface="맑은 고딕"/>
-        <a:font script="Hans" typeface="宋体"/>
-        <a:font script="Hant" typeface="新細明體"/>
-        <a:font script="Arab" typeface="Times New Roman"/>
-        <a:font script="Hebr" typeface="Times New Roman"/>
-        <a:font script="Thai" typeface="Angsana New"/>
-        <a:font script="Ethi" typeface="Nyala"/>
-        <a:font script="Beng" typeface="Vrinda"/>
-        <a:font script="Gujr" typeface="Shruti"/>
-        <a:font script="Khmr" typeface="MoolBoran"/>
-        <a:font script="Knda" typeface="Tunga"/>
-        <a:font script="Guru" typeface="Raavi"/>
-        <a:font script="Cans" typeface="Euphemia"/>
-        <a:font script="Cher" typeface="Plantagenet Cherokee"/>
-        <a:font script="Yiii" typeface="Microsoft Yi Baiti"/>
-        <a:font script="Tibt" typeface="Microsoft Himalaya"/>
-        <a:font script="Thaa" typeface="MV Boli"/>
-        <a:font script="Deva" typeface="Mangal"/>
-        <a:font script="Telu" typeface="Gautami"/>
-        <a:font script="Taml" typeface="Latha"/>
-        <a:font script="Syrc" typeface="Estrangelo Edessa"/>
-        <a:font script="Orya" typeface="Kalinga"/>
-        <a:font script="Mlym" typeface="Kartika"/>
-        <a:font script="Laoo" typeface="DokChampa"/>
-        <a:font script="Sinh" typeface="Iskoola Pota"/>
-        <a:font script="Mong" typeface="Mongolian Baiti"/>
-        <a:font script="Viet" typeface="Times New Roman"/>
-        <a:font script="Uigh" typeface="Microsoft Uighur"/>
-        <a:font script="Geor" typeface="Sylfaen"/>
-      </a:majorFont>
-      <a:minorFont>
-        <a:latin typeface="Arial"/>
-        <a:ea typeface=""/>
-        <a:cs typeface=""/>
-        <a:font script="Jpan" typeface="ＭＳ Ｐゴシック"/>
-        <a:font script="Hang" typeface="맑은 고딕"/>
-        <a:font script="Hans" typeface="宋体"/>
-        <a:font script="Hant" typeface="新細明體"/>
-        <a:font script="Arab" typeface="Arial"/>
-        <a:font script="Hebr" typeface="Arial"/>
-        <a:font script="Thai" typeface="Cordia New"/>
-        <a:font script="Ethi" typeface="Nyala"/>
-        <a:font script="Beng" typeface="Vrinda"/>
-        <a:font script="Gujr" typeface="Shruti"/>
-        <a:font script="Khmr" typeface="DaunPenh"/>
-        <a:font script="Knda" typeface="Tunga"/>
-        <a:font script="Guru" typeface="Raavi"/>
-        <a:font script="Cans" typeface="Euphemia"/>
-        <a:font script="Cher" typeface="Plantagenet Cherokee"/>
-        <a:font script="Yiii" typeface="Microsoft Yi Baiti"/>
-        <a:font script="Tibt" typeface="Microsoft Himalaya"/>
-        <a:font script="Thaa" typeface="MV Boli"/>
-        <a:font script="Deva" typeface="Mangal"/>
-        <a:font script="Telu" typeface="Gautami"/>
-        <a:font script="Taml" typeface="Latha"/>
-        <a:font script="Syrc" typeface="Estrangelo Edessa"/>
-        <a:font script="Orya" typeface="Kalinga"/>
-        <a:font script="Mlym" typeface="Kartika"/>
-        <a:font script="Laoo" typeface="DokChampa"/>
-        <a:font script="Sinh" typeface="Iskoola Pota"/>
-        <a:font script="Mong" typeface="Mongolian Baiti"/>
-        <a:font script="Viet" typeface="Arial"/>
-        <a:font script="Uigh" typeface="Microsoft Uighur"/>
-        <a:font script="Geor" typeface="Sylfaen"/>
-      </a:minorFont>
-    </a:fontScheme>
-    <a:fmtScheme name="Office">
-      <a:fillStyleLst>
-        <a:solidFill>
-          <a:schemeClr val="phClr"/>
-        </a:solidFill>
-        <a:gradFill rotWithShape="1">
-          <a:gsLst>
-            <a:gs pos="0">
-              <a:schemeClr val="phClr">
-                <a:tint val="50000"/>
-                <a:satMod val="300000"/>
-              </a:schemeClr>
-            </a:gs>
-            <a:gs pos="35000">
-              <a:schemeClr val="phClr">
-                <a:tint val="37000"/>
-                <a:satMod val="300000"/>
-              </a:schemeClr>
-            </a:gs>
-            <a:gs pos="100000">
-              <a:schemeClr val="phClr">
-                <a:tint val="15000"/>
-                <a:satMod val="350000"/>
-              </a:schemeClr>
-            </a:gs>
-          </a:gsLst>
-          <a:lin ang="16200000" scaled="1"/>
-        </a:gradFill>
-        <a:gradFill rotWithShape="1">
-          <a:gsLst>
-            <a:gs pos="0">
-              <a:schemeClr val="phClr">
-                <a:tint val="100000"/>
-                <a:shade val="100000"/>
-                <a:satMod val="130000"/>
-              </a:schemeClr>
-            </a:gs>
-            <a:gs pos="100000">
-              <a:schemeClr val="phClr">
-                <a:tint val="50000"/>
-                <a:shade val="100000"/>
-                <a:satMod val="350000"/>
-              </a:schemeClr>
-            </a:gs>
-          </a:gsLst>
-          <a:lin ang="16200000" scaled="0"/>
-        </a:gradFill>
-      </a:fillStyleLst>
-      <a:lnStyleLst>
-        <a:ln w="9525" cap="flat" cmpd="sng" algn="ctr">
-          <a:solidFill>
-            <a:schemeClr val="phClr">
-              <a:shade val="95000"/>
-              <a:satMod val="105000"/>
-            </a:schemeClr>
-          </a:solidFill>
-          <a:prstDash val="solid"/>
-        </a:ln>
-        <a:ln w="25400" cap="flat" cmpd="sng" algn="ctr">
-          <a:solidFill>
-            <a:schemeClr val="phClr"/>
-          </a:solidFill>
-          <a:prstDash val="solid"/>
-        </a:ln>
-        <a:ln w="38100" cap="flat" cmpd="sng" algn="ctr">
-          <a:solidFill>
-            <a:schemeClr val="phClr"/>
-          </a:solidFill>
-          <a:prstDash val="solid"/>
-        </a:ln>
-      </a:lnStyleLst>
-      <a:effectStyleLst>
-        <a:effectStyle>
-          <a:effectLst>
-            <a:outerShdw blurRad="40000" dist="20000" dir="5400000" rotWithShape="0">
-              <a:srgbClr val="000000">
-                <a:alpha val="38000"/>
-              </a:srgbClr>
-            </a:outerShdw>
-          </a:effectLst>
-        </a:effectStyle>
-        <a:effectStyle>
-          <a:effectLst>
-            <a:outerShdw blurRad="40000" dist="23000" dir="5400000" rotWithShape="0">
-              <a:srgbClr val="000000">
-                <a:alpha val="35000"/>
-              </a:srgbClr>
-            </a:outerShdw>
-          </a:effectLst>
-        </a:effectStyle>
-        <a:effectStyle>
-          <a:effectLst>
-            <a:outerShdw blurRad="40000" dist="23000" dir="5400000" rotWithShape="0">
-              <a:srgbClr val="000000">
-                <a:alpha val="35000"/>
-              </a:srgbClr>
-            </a:outerShdw>
-          </a:effectLst>
-          <a:scene3d>
-            <a:camera prst="orthographicFront">
-              <a:rot lat="0" lon="0" rev="0"/>
-            </a:camera>
-            <a:lightRig rig="threePt" dir="t">
-              <a:rot lat="0" lon="0" rev="1200000"/>
-            </a:lightRig>
-          </a:scene3d>
-          <a:sp3d>
-            <a:bevelT w="63500" h="25400"/>
-          </a:sp3d>
-        </a:effectStyle>
-      </a:effectStyleLst>
-      <a:bgFillStyleLst>
-        <a:solidFill>
-          <a:schemeClr val="phClr"/>
-        </a:solidFill>
-        <a:gradFill rotWithShape="1">
-          <a:gsLst>
-            <a:gs pos="0">
-              <a:schemeClr val="phClr">
-                <a:tint val="40000"/>
-                <a:satMod val="350000"/>
-              </a:schemeClr>
-            </a:gs>
-            <a:gs pos="40000">
-              <a:schemeClr val="phClr">
-                <a:tint val="45000"/>
-                <a:shade val="99000"/>
-                <a:satMod val="350000"/>
-              </a:schemeClr>
-            </a:gs>
-            <a:gs pos="100000">
-              <a:schemeClr val="phClr">
-                <a:shade val="20000"/>
-                <a:satMod val="255000"/>
-              </a:schemeClr>
-            </a:gs>
-          </a:gsLst>
-          <a:path path="circle">
-            <a:fillToRect l="50000" t="-80000" r="50000" b="180000"/>
-          </a:path>
-        </a:gradFill>
-        <a:gradFill rotWithShape="1">
-          <a:gsLst>
-            <a:gs pos="0">
-              <a:schemeClr val="phClr">
-                <a:tint val="80000"/>
-                <a:satMod val="300000"/>
-              </a:schemeClr>
-            </a:gs>
-            <a:gs pos="100000">
-              <a:schemeClr val="phClr">
-                <a:shade val="30000"/>
-                <a:satMod val="200000"/>
-              </a:schemeClr>
-            </a:gs>
-          </a:gsLst>
-          <a:path path="circle">
-            <a:fillToRect l="50000" t="50000" r="50000" b="50000"/>
-          </a:path>
-        </a:gradFill>
-      </a:bgFillStyleLst>
-    </a:fmtScheme>
-  </a:themeElements>
-</a:theme>
 </file>
</xml_diff>